<commit_message>
Arahkan tombol data interaktif di PPTX ke situs GitHub Pages
Tombol "LIHAT DATA INTERAKTIF" di kanan atas kedua slide sebelumnya
menunjuk ke file HTML lokal. Sekarang menunjuk ke alamat situs, dan ikon
di dalam tombol ikut diberi hyperlink.

Co-Authored-By: Claude Fable 5.1 <noreply@anthropic.com>
Claude-Session: https://claude.ai/code/session_01PiLKToUGYGBsK3FYK4ECrk
</commit_message>
<xml_diff>
--- a/BHP-Medan-Paparan-Klaster-1.pptx
+++ b/BHP-Medan-Paparan-Klaster-1.pptx
@@ -3518,7 +3518,10 @@
       </p:sp>
       <p:pic>
         <p:nvPicPr>
-          <p:cNvPr id="50" name="link_data_i" descr="preencoded.png"/>
+          <p:cNvPr id="50" name="link_data_i" descr="preencoded.png">
+            <a:hlinkClick r:id="rId3"/>
+            <a:hlinkHover r:id="rId3" highlightClick="1"/>
+          </p:cNvPr>
           <p:cNvPicPr>
             <a:picLocks noChangeAspect="1"/>
           </p:cNvPicPr>
@@ -8736,7 +8739,10 @@
       </p:sp>
       <p:pic>
         <p:nvPicPr>
-          <p:cNvPr id="37" name="link_data_i" descr="preencoded.png"/>
+          <p:cNvPr id="37" name="link_data_i" descr="preencoded.png">
+            <a:hlinkClick r:id="rId8"/>
+            <a:hlinkHover r:id="rId8" highlightClick="1"/>
+          </p:cNvPr>
           <p:cNvPicPr>
             <a:picLocks noChangeAspect="1"/>
           </p:cNvPicPr>

</xml_diff>

<commit_message>
Dashboard mengikuti Paparan, Narasi, dan Data Pendukung versi final
- Istilah 'diangkat' menjadi 'ditunjuk' (Tabel I.4, I.5, kartu PT Jasa
  Prima Mandiri, Usulan Pasal A dan C).
- Usulan Pasal B ayat (2) dan (4) mengikuti rumusan final.
- Catatan 'kurator yang diangkat adalah usulan pemohon' dihapus dari
  Intinya karena tidak lagi ada di Data Pendukung.
- Tugas keperdataan dijalankan 'BHP dalam kedudukannya sebagai pelaksana
  tugas keperdataan'; dasar PNBP ditambah Permenkum Nomor 20 Tahun 2025.
- Unduh PPTX memakai Paparan final.

Co-Authored-By: Claude Opus 5.5 <noreply@anthropic.com>
Claude-Session: https://claude.ai/code/session_015oqaefxqL3PuaXCVJu5SrV
</commit_message>
<xml_diff>
--- a/BHP-Medan-Paparan-Klaster-1.pptx
+++ b/BHP-Medan-Paparan-Klaster-1.pptx
@@ -3145,7 +3145,7 @@
                 <a:cs typeface="Calibri"/>
                 <a:sym typeface="Calibri"/>
               </a:rPr>
-              <a:t>Bagaimana mekanisme BHP sebagai kurator, dan adakah kendala saat berhadapan dengan kurator privat dari asosiasi?</a:t>
+              <a:t>Bagaimana mekanisme BHP sebagai kurator, dan adakah kendala saat berhadapan dengan kurator perseorangan?</a:t>
             </a:r>
             <a:endParaRPr sz="1400">
               <a:solidFill>
@@ -3776,7 +3776,7 @@
                 <a:cs typeface="Calibri"/>
                 <a:sym typeface="Calibri"/>
               </a:rPr>
-              <a:t>, karena tugas keperdataan BHP dan tugas BHP sebagai kurator adalah dua hal yang berbeda. Yang dipisahkan adalah dasar hukum, pelaksanaan, dan pertanggungjawabannya, bukan lembaganya.</a:t>
+              <a:t>, karena tugas keperdataan BHP dan tugas BHP sebagai kurator adalah dua hal yang berbeda. Yang dipisahkan adalah dasar hukum, pelaksanaan, dan pertanggungjawabannya.</a:t>
             </a:r>
             <a:endParaRPr sz="1300"/>
           </a:p>

</xml_diff>

<commit_message>
Dashboard mengikuti Narasi, Ringkasan Paparan, Data Pendukung, dan Paparan terbaru
- Pembuka: angka sesuai Paparan (9 perkara berjalan, 3 dari 26 perkara lima
  BHP 2023 sampai 2025, Rp47,35 M, 1 dari 16 putusan).
- Tab SOP Kepailitan diganti tab Mekanisme (Pertanyaan 1): dasar Pasal 1
  angka 5 dan 15 ayat (2), alur mekanisme, Tabel 1 perbedaan kelembagaan,
  BHP tidak berwenang sebagai Pengurus PKPU, dua kendala, risiko hukum dan
  DIPA.
- Tab Pembagian Peran menjadi Pemisahan Peran (Pertanyaan 2 dan 3):
  lembaga pemerintah dan profesi, Tabel 2 delapan fungsi BHP, pengaruh
  pemisahan, Tabel 3 tiga kriteria perkara, tiga butir Saran.
- Lampiran II memakai Usulan Pasal A, B, C terbaru.
- Data perkara tidak diubah; rujukan tabel di Data Lengkap menyesuaikan
  penomoran baru. Unduh PPTX memakai Paparan terbaru.

Co-Authored-By: Claude Opus 5.5 <noreply@anthropic.com>
Claude-Session: https://claude.ai/code/session_015oqaefxqL3PuaXCVJu5SrV
</commit_message>
<xml_diff>
--- a/BHP-Medan-Paparan-Klaster-1.pptx
+++ b/BHP-Medan-Paparan-Klaster-1.pptx
@@ -2774,17 +2774,17 @@
             <a:r>
               <a:rPr b="1" i="0" lang="en-US" sz="1100" u="none" cap="none" strike="noStrike">
                 <a:solidFill>
-                  <a:srgbClr val="7A1F2B"/>
+                  <a:srgbClr val="6B6B6B"/>
                 </a:solidFill>
                 <a:latin typeface="Calibri"/>
                 <a:ea typeface="Calibri"/>
                 <a:cs typeface="Calibri"/>
                 <a:sym typeface="Calibri"/>
               </a:rPr>
-              <a:t>Klaster Tumpang Tindih Kewenangan. </a:t>
+              <a:t>Klaster Tumpang Tindih Kewenangan.</a:t>
             </a:r>
             <a:r>
-              <a:rPr b="0" i="0" lang="en-US" sz="1100" u="none" cap="none" strike="noStrike">
+              <a:rPr i="0" lang="en-US" sz="1100" u="none" cap="none" strike="noStrike">
                 <a:solidFill>
                   <a:srgbClr val="6B6B6B"/>
                 </a:solidFill>
@@ -2793,7 +2793,7 @@
                 <a:cs typeface="Calibri"/>
                 <a:sym typeface="Calibri"/>
               </a:rPr>
-              <a:t>Tiga kotak di bawah menjawab Pertanyaan 1, 2, dan 3 secara berurutan, masing-masing dengan bukti dari perkara BHP Medan.</a:t>
+              <a:t> Jawaban Pertanyaan 1–3, selaras dengan Naskah RDP bersama lima BHP.</a:t>
             </a:r>
             <a:endParaRPr b="0" i="0" sz="1100" u="none" cap="none" strike="noStrike">
               <a:solidFill>
@@ -3202,6 +3202,18 @@
               <a:buAutoNum type="arabicPeriod"/>
             </a:pPr>
             <a:r>
+              <a:rPr lang="en-US" sz="1600" b="1">
+                <a:solidFill>
+                  <a:srgbClr val="2B2B2B"/>
+                </a:solidFill>
+                <a:latin typeface="Calibri"/>
+                <a:ea typeface="Calibri"/>
+                <a:cs typeface="Calibri"/>
+                <a:sym typeface="Calibri"/>
+              </a:rPr>
+              <a:t>Mekanisme:</a:t>
+            </a:r>
+            <a:r>
               <a:rPr lang="en-US" sz="1600">
                 <a:solidFill>
                   <a:srgbClr val="2B2B2B"/>
@@ -3211,7 +3223,7 @@
                 <a:cs typeface="Calibri"/>
                 <a:sym typeface="Calibri"/>
               </a:rPr>
-              <a:t>Kendala pertama adalah ketika kurator BHP bekerja sama dengan kurator perseorangan, belum adanya aturan pembagian imbalan dan tanggung jawab. Oleh karena itu, perlu aturan tegas tentang pembagian imbalan jasa.</a:t>
+              <a:t> sesuai Pasal 1 angka 5 dan 15 ayat (2) UU 37/2004, sama seperti kurator perseorangan di bawah Hakim Pengawas; pembedanya: ditunjuk sebagai institusi, pelaksana ASN, imbalan jasa PNBP. BHP tidak berwenang sebagai Pengurus PKPU.</a:t>
             </a:r>
             <a:endParaRPr sz="1300"/>
           </a:p>
@@ -3234,6 +3246,18 @@
               <a:buAutoNum type="arabicPeriod"/>
             </a:pPr>
             <a:r>
+              <a:rPr lang="en-US" sz="1600" b="1">
+                <a:solidFill>
+                  <a:srgbClr val="2B2B2B"/>
+                </a:solidFill>
+                <a:latin typeface="Calibri"/>
+                <a:ea typeface="Calibri"/>
+                <a:cs typeface="Calibri"/>
+                <a:sym typeface="Calibri"/>
+              </a:rPr>
+              <a:t>Kendala:</a:t>
+            </a:r>
+            <a:r>
               <a:rPr lang="en-US" sz="1600">
                 <a:solidFill>
                   <a:srgbClr val="2B2B2B"/>
@@ -3243,7 +3267,7 @@
                 <a:cs typeface="Calibri"/>
                 <a:sym typeface="Calibri"/>
               </a:rPr>
-              <a:t>Kendala kedua adalah dalam komunikasi dalam hal PKPU oleh kurator perseorangan dan kepailitan oleh Kurator BHP. Dengan demikian, diusulkan BHP juga menjadi pengurus (PKPU).</a:t>
+              <a:t> pembagian tugas, tanggung jawab, dan imbalan jasa dalam tugas bersama belum jelas; pada pailit dari PKPU atau sebagai Kurator pengganti, informasi dan serah terima terbatas.</a:t>
             </a:r>
             <a:endParaRPr sz="1600">
               <a:solidFill>
@@ -3755,7 +3779,7 @@
               <a:buNone/>
             </a:pPr>
             <a:r>
-              <a:rPr b="1" lang="en-US" sz="1600">
+              <a:rPr lang="en-US" sz="1600" b="1">
                 <a:solidFill>
                   <a:schemeClr val="dk1"/>
                 </a:solidFill>
@@ -3764,7 +3788,7 @@
                 <a:cs typeface="Calibri"/>
                 <a:sym typeface="Calibri"/>
               </a:rPr>
-              <a:t>Perlu</a:t>
+              <a:t>Perlu.</a:t>
             </a:r>
             <a:r>
               <a:rPr lang="en-US" sz="1600">
@@ -3776,7 +3800,7 @@
                 <a:cs typeface="Calibri"/>
                 <a:sym typeface="Calibri"/>
               </a:rPr>
-              <a:t>, karena tugas keperdataan BHP dan tugas BHP sebagai kurator adalah dua hal yang berbeda. Yang dipisahkan adalah dasar hukum, pelaksanaan, dan pertanggungjawabannya.</a:t>
+              <a:t> Kurator kepailitan adalah salah satu dari 8 fungsi BHP, dan dalam fungsi itu BHP bertindak sebagai lembaga pemerintah, bukan profesi: terikat UU Kepailitan dan PKPU serta UU ASN, diawasi Hakim Pengawas dan APIP.</a:t>
             </a:r>
             <a:endParaRPr sz="1300"/>
           </a:p>
@@ -3803,31 +3827,7 @@
                 <a:cs typeface="Calibri"/>
                 <a:sym typeface="Calibri"/>
               </a:rPr>
-              <a:t>Dalam kepailitan, BHP berkedudukan sebagai kurator sebagaimana kurator perseorangan yang ditunjuk pengadilan. Sedangkan dalam tugas pokok dan fungsi lain, BHP berkedudukan sebagai wali pengawas, </a:t>
-            </a:r>
-            <a:r>
-              <a:rPr lang="en-US" sz="1600">
-                <a:solidFill>
-                  <a:schemeClr val="dk1"/>
-                </a:solidFill>
-                <a:latin typeface="Calibri"/>
-                <a:ea typeface="Calibri"/>
-                <a:cs typeface="Calibri"/>
-                <a:sym typeface="Calibri"/>
-              </a:rPr>
-              <a:t>pengampu pengawas</a:t>
-            </a:r>
-            <a:r>
-              <a:rPr lang="en-US" sz="1600">
-                <a:solidFill>
-                  <a:schemeClr val="dk1"/>
-                </a:solidFill>
-                <a:latin typeface="Calibri"/>
-                <a:ea typeface="Calibri"/>
-                <a:cs typeface="Calibri"/>
-                <a:sym typeface="Calibri"/>
-              </a:rPr>
-              <a:t>, dll sebagaimana yang diatur dalam KUHPerdata.</a:t>
+              <a:t>Karena itu, pengaturan profesi (persyaratan, sertifikasi, registrasi, organisasi profesi) tidak berkaitan dengan BHP. RUU perlu mengatur Dewan Etik dan Kode Etik Bersama, dengan nomenklatur “RUU Kurator dan Pengurus”.</a:t>
             </a:r>
             <a:endParaRPr sz="1300"/>
           </a:p>
@@ -4223,7 +4223,7 @@
               <a:buNone/>
             </a:pPr>
             <a:r>
-              <a:rPr b="1" lang="en-US" sz="1600">
+              <a:rPr lang="en-US" sz="1600" b="1">
                 <a:solidFill>
                   <a:schemeClr val="dk1"/>
                 </a:solidFill>
@@ -4232,7 +4232,7 @@
                 <a:cs typeface="Calibri"/>
                 <a:sym typeface="Calibri"/>
               </a:rPr>
-              <a:t>BHP setuju</a:t>
+              <a:t>BHP Medan pada prinsipnya setuju</a:t>
             </a:r>
             <a:r>
               <a:rPr lang="en-US" sz="1600">
@@ -4244,31 +4244,7 @@
                 <a:cs typeface="Calibri"/>
                 <a:sym typeface="Calibri"/>
               </a:rPr>
-              <a:t>, dan hal tersebut sudah semestinya diatur untuk perkara khusus seperti debitor yang meninggal tanpa ahli waris atau hartanya tidak terurus, </a:t>
-            </a:r>
-            <a:r>
-              <a:rPr lang="en-US" sz="1600">
-                <a:solidFill>
-                  <a:schemeClr val="dk1"/>
-                </a:solidFill>
-                <a:latin typeface="Calibri"/>
-                <a:ea typeface="Calibri"/>
-                <a:cs typeface="Calibri"/>
-                <a:sym typeface="Calibri"/>
-              </a:rPr>
-              <a:t>debitor yang tidak diketahui keberadaannya, perkara yang ahli waris atau pihak yang berkepentingan masih di bawah umur atau dalam pengampuan,</a:t>
-            </a:r>
-            <a:r>
-              <a:rPr lang="en-US" sz="1600">
-                <a:solidFill>
-                  <a:schemeClr val="dk1"/>
-                </a:solidFill>
-                <a:latin typeface="Calibri"/>
-                <a:ea typeface="Calibri"/>
-                <a:cs typeface="Calibri"/>
-                <a:sym typeface="Calibri"/>
-              </a:rPr>
-              <a:t> perkara pekerja, perkara dengan harta kecil, dan perkara yang kehilangan kurator.</a:t>
+              <a:t> untuk perkara yang beririsan dengan tugas keperdataan BHP: debitor meninggal tanpa ahli waris atau hartanya tidak terurus, debitor tidak diketahui keberadaannya, serta ahli waris di bawah umur atau dalam pengampuan.</a:t>
             </a:r>
             <a:endParaRPr sz="1300"/>
           </a:p>
@@ -4295,7 +4271,7 @@
                 <a:cs typeface="Calibri"/>
                 <a:sym typeface="Calibri"/>
               </a:rPr>
-              <a:t>Di luar itu, para pihak tetap bebas memilih kurator. RUU Profesi Kurator cukup memuat dasar penugasan ini, sedangkan kriteria dan tata cara penunjukannya diatur dalam RUU Kepailitan dan PKPU.</a:t>
+              <a:t>Karena kedudukan BHP sebagai Kurator bersumber dari UU Kepailitan dan PKPU, penugasan ini tepat diatur di sana, disertai akses informasi perkara dan fleksibilitas anggaran DIPA. Di luar itu, para pihak tetap bebas mengusulkan kurator.</a:t>
             </a:r>
             <a:endParaRPr sz="1300"/>
           </a:p>
@@ -4428,7 +4404,7 @@
                 <a:cs typeface="Calibri"/>
                 <a:sym typeface="Calibri"/>
               </a:rPr>
-              <a:t>Sumber: Buku Register Kepailitan dan laporan pengurusan BHP Medan; SIPP PN Medan per 2 Oktober 2026, diolah. Dihitung per putusan pailit, bukan per permohonan.</a:t>
+              <a:t>Sumber: Naskah RDP bersama lima BHP; Buku Register Kepailitan BHP Medan; SIPP PN Medan per 2 Oktober 2026, diolah.</a:t>
             </a:r>
             <a:endParaRPr sz="900">
               <a:solidFill>
@@ -11280,7 +11256,7 @@
                   <a:cs typeface="Calibri"/>
                   <a:sym typeface="Calibri"/>
                 </a:rPr>
-                <a:t>perkara kepailitan sedang ditangani</a:t>
+                <a:t>perkara berjalan (termasuk putusan sebelum 2023)</a:t>
               </a:r>
               <a:endParaRPr sz="1200">
                 <a:solidFill>
@@ -11463,7 +11439,7 @@
                 <a:buNone/>
               </a:pPr>
               <a:r>
-                <a:rPr b="1" lang="en-US" sz="2600">
+                <a:rPr lang="en-US" sz="2600">
                   <a:solidFill>
                     <a:srgbClr val="C9A24A"/>
                   </a:solidFill>
@@ -11472,7 +11448,7 @@
                   <a:cs typeface="Cambria"/>
                   <a:sym typeface="Cambria"/>
                 </a:rPr>
-                <a:t>1 dari 9</a:t>
+                <a:t>3 dari 26</a:t>
               </a:r>
               <a:endParaRPr sz="2600">
                 <a:solidFill>
@@ -11538,31 +11514,7 @@
                   <a:cs typeface="Calibri"/>
                   <a:sym typeface="Calibri"/>
                 </a:rPr>
-                <a:t>putusan pailit 2025 </a:t>
-              </a:r>
-              <a:r>
-                <a:rPr lang="en-US" sz="1200">
-                  <a:solidFill>
-                    <a:srgbClr val="FFFFFF"/>
-                  </a:solidFill>
-                  <a:latin typeface="Calibri"/>
-                  <a:ea typeface="Calibri"/>
-                  <a:cs typeface="Calibri"/>
-                  <a:sym typeface="Calibri"/>
-                </a:rPr>
-                <a:t>menunjuk</a:t>
-              </a:r>
-              <a:r>
-                <a:rPr lang="en-US" sz="1200">
-                  <a:solidFill>
-                    <a:srgbClr val="FFFFFF"/>
-                  </a:solidFill>
-                  <a:latin typeface="Calibri"/>
-                  <a:ea typeface="Calibri"/>
-                  <a:cs typeface="Calibri"/>
-                  <a:sym typeface="Calibri"/>
-                </a:rPr>
-                <a:t> BHP</a:t>
+                <a:t>perkara 2023–2025 lima BHP ditangani BHP Medan</a:t>
               </a:r>
               <a:endParaRPr sz="1200">
                 <a:solidFill>
@@ -11616,7 +11568,7 @@
                 <a:buNone/>
               </a:pPr>
               <a:r>
-                <a:rPr b="1" lang="en-US" sz="2600">
+                <a:rPr lang="en-US" sz="2600">
                   <a:solidFill>
                     <a:srgbClr val="C9A24A"/>
                   </a:solidFill>
@@ -11625,7 +11577,7 @@
                   <a:cs typeface="Cambria"/>
                   <a:sym typeface="Cambria"/>
                 </a:rPr>
-                <a:t>0 dari 7</a:t>
+                <a:t>1 dari 16</a:t>
               </a:r>
               <a:endParaRPr sz="2600">
                 <a:solidFill>
@@ -11691,31 +11643,7 @@
                   <a:cs typeface="Calibri"/>
                   <a:sym typeface="Calibri"/>
                 </a:rPr>
-                <a:t>putusan pailit 2026 </a:t>
-              </a:r>
-              <a:r>
-                <a:rPr lang="en-US" sz="1200">
-                  <a:solidFill>
-                    <a:srgbClr val="FFFFFF"/>
-                  </a:solidFill>
-                  <a:latin typeface="Calibri"/>
-                  <a:ea typeface="Calibri"/>
-                  <a:cs typeface="Calibri"/>
-                  <a:sym typeface="Calibri"/>
-                </a:rPr>
-                <a:t>menunjuk</a:t>
-              </a:r>
-              <a:r>
-                <a:rPr lang="en-US" sz="1200">
-                  <a:solidFill>
-                    <a:srgbClr val="FFFFFF"/>
-                  </a:solidFill>
-                  <a:latin typeface="Calibri"/>
-                  <a:ea typeface="Calibri"/>
-                  <a:cs typeface="Calibri"/>
-                  <a:sym typeface="Calibri"/>
-                </a:rPr>
-                <a:t> BHP</a:t>
+                <a:t>putusan pailit 2025–2026 menunjuk BHP Medan</a:t>
               </a:r>
               <a:endParaRPr sz="1200">
                 <a:solidFill>

</xml_diff>